<commit_message>
Updates to A01 B01 B02 for first two sessions Summer 2026
</commit_message>
<xml_diff>
--- a/Lecture slides/AMOS A01 - Introduction.pptx
+++ b/Lecture slides/AMOS A01 - Introduction.pptx
@@ -2121,7 +2121,7 @@
       </p:grpSpPr>
       <p:sp>
         <p:nvSpPr>
-          <p:cNvPr id="241" name="Google Shape;241;g2cc858d6e65_0_0:notes"/>
+          <p:cNvPr id="241" name="Google Shape;241;g23985d0d2d4_0_100:notes"/>
           <p:cNvSpPr/>
           <p:nvPr>
             <p:ph idx="2" type="sldImg"/>
@@ -2156,7 +2156,7 @@
       </p:sp>
       <p:sp>
         <p:nvSpPr>
-          <p:cNvPr id="242" name="Google Shape;242;g2cc858d6e65_0_0:notes"/>
+          <p:cNvPr id="242" name="Google Shape;242;g23985d0d2d4_0_100:notes"/>
           <p:cNvSpPr txBox="1"/>
           <p:nvPr>
             <p:ph idx="1" type="body"/>
@@ -2220,7 +2220,7 @@
       </p:grpSpPr>
       <p:sp>
         <p:nvSpPr>
-          <p:cNvPr id="249" name="Google Shape;249;g23985d0d2d4_0_100:notes"/>
+          <p:cNvPr id="249" name="Google Shape;249;g126320e9147_0_147:notes"/>
           <p:cNvSpPr/>
           <p:nvPr>
             <p:ph idx="2" type="sldImg"/>
@@ -2255,7 +2255,7 @@
       </p:sp>
       <p:sp>
         <p:nvSpPr>
-          <p:cNvPr id="250" name="Google Shape;250;g23985d0d2d4_0_100:notes"/>
+          <p:cNvPr id="250" name="Google Shape;250;g126320e9147_0_147:notes"/>
           <p:cNvSpPr txBox="1"/>
           <p:nvPr>
             <p:ph idx="1" type="body"/>
@@ -2319,7 +2319,7 @@
       </p:grpSpPr>
       <p:sp>
         <p:nvSpPr>
-          <p:cNvPr id="257" name="Google Shape;257;g126320e9147_0_147:notes"/>
+          <p:cNvPr id="257" name="Google Shape;257;g3d6168d35e0_0_96:notes"/>
           <p:cNvSpPr/>
           <p:nvPr>
             <p:ph idx="2" type="sldImg"/>
@@ -2354,7 +2354,7 @@
       </p:sp>
       <p:sp>
         <p:nvSpPr>
-          <p:cNvPr id="258" name="Google Shape;258;g126320e9147_0_147:notes"/>
+          <p:cNvPr id="258" name="Google Shape;258;g3d6168d35e0_0_96:notes"/>
           <p:cNvSpPr txBox="1"/>
           <p:nvPr>
             <p:ph idx="1" type="body"/>
@@ -2404,7 +2404,7 @@
   <p:cSld>
     <p:spTree>
       <p:nvGrpSpPr>
-        <p:cNvPr id="264" name="Shape 264"/>
+        <p:cNvPr id="263" name="Shape 263"/>
         <p:cNvGrpSpPr/>
         <p:nvPr/>
       </p:nvGrpSpPr>
@@ -2418,7 +2418,7 @@
       </p:grpSpPr>
       <p:sp>
         <p:nvSpPr>
-          <p:cNvPr id="265" name="Google Shape;265;g126320e9147_0_94:notes"/>
+          <p:cNvPr id="264" name="Google Shape;264;g126320e9147_0_94:notes"/>
           <p:cNvSpPr/>
           <p:nvPr>
             <p:ph idx="2" type="sldImg"/>
@@ -2453,7 +2453,7 @@
       </p:sp>
       <p:sp>
         <p:nvSpPr>
-          <p:cNvPr id="266" name="Google Shape;266;g126320e9147_0_94:notes"/>
+          <p:cNvPr id="265" name="Google Shape;265;g126320e9147_0_94:notes"/>
           <p:cNvSpPr txBox="1"/>
           <p:nvPr>
             <p:ph idx="1" type="body"/>
@@ -2503,7 +2503,7 @@
   <p:cSld>
     <p:spTree>
       <p:nvGrpSpPr>
-        <p:cNvPr id="271" name="Shape 271"/>
+        <p:cNvPr id="270" name="Shape 270"/>
         <p:cNvGrpSpPr/>
         <p:nvPr/>
       </p:nvGrpSpPr>
@@ -2517,7 +2517,7 @@
       </p:grpSpPr>
       <p:sp>
         <p:nvSpPr>
-          <p:cNvPr id="272" name="Google Shape;272;g126320e9147_0_210:notes"/>
+          <p:cNvPr id="271" name="Google Shape;271;g126320e9147_0_210:notes"/>
           <p:cNvSpPr/>
           <p:nvPr>
             <p:ph idx="2" type="sldImg"/>
@@ -2552,7 +2552,7 @@
       </p:sp>
       <p:sp>
         <p:nvSpPr>
-          <p:cNvPr id="273" name="Google Shape;273;g126320e9147_0_210:notes"/>
+          <p:cNvPr id="272" name="Google Shape;272;g126320e9147_0_210:notes"/>
           <p:cNvSpPr txBox="1"/>
           <p:nvPr>
             <p:ph idx="1" type="body"/>
@@ -2602,7 +2602,7 @@
   <p:cSld>
     <p:spTree>
       <p:nvGrpSpPr>
-        <p:cNvPr id="278" name="Shape 278"/>
+        <p:cNvPr id="277" name="Shape 277"/>
         <p:cNvGrpSpPr/>
         <p:nvPr/>
       </p:nvGrpSpPr>
@@ -2616,7 +2616,7 @@
       </p:grpSpPr>
       <p:sp>
         <p:nvSpPr>
-          <p:cNvPr id="279" name="Google Shape;279;g126320e9147_0_223:notes"/>
+          <p:cNvPr id="278" name="Google Shape;278;g126320e9147_0_223:notes"/>
           <p:cNvSpPr/>
           <p:nvPr>
             <p:ph idx="2" type="sldImg"/>
@@ -2651,7 +2651,7 @@
       </p:sp>
       <p:sp>
         <p:nvSpPr>
-          <p:cNvPr id="280" name="Google Shape;280;g126320e9147_0_223:notes"/>
+          <p:cNvPr id="279" name="Google Shape;279;g126320e9147_0_223:notes"/>
           <p:cNvSpPr txBox="1"/>
           <p:nvPr>
             <p:ph idx="1" type="body"/>
@@ -2701,7 +2701,7 @@
   <p:cSld>
     <p:spTree>
       <p:nvGrpSpPr>
-        <p:cNvPr id="285" name="Shape 285"/>
+        <p:cNvPr id="284" name="Shape 284"/>
         <p:cNvGrpSpPr/>
         <p:nvPr/>
       </p:nvGrpSpPr>
@@ -2715,7 +2715,7 @@
       </p:grpSpPr>
       <p:sp>
         <p:nvSpPr>
-          <p:cNvPr id="286" name="Google Shape;286;g23985d0d2d4_0_38:notes"/>
+          <p:cNvPr id="285" name="Google Shape;285;g23985d0d2d4_0_38:notes"/>
           <p:cNvSpPr/>
           <p:nvPr>
             <p:ph idx="2" type="sldImg"/>
@@ -2750,7 +2750,7 @@
       </p:sp>
       <p:sp>
         <p:nvSpPr>
-          <p:cNvPr id="287" name="Google Shape;287;g23985d0d2d4_0_38:notes"/>
+          <p:cNvPr id="286" name="Google Shape;286;g23985d0d2d4_0_38:notes"/>
           <p:cNvSpPr txBox="1"/>
           <p:nvPr>
             <p:ph idx="1" type="body"/>
@@ -2800,7 +2800,7 @@
   <p:cSld>
     <p:spTree>
       <p:nvGrpSpPr>
-        <p:cNvPr id="291" name="Shape 291"/>
+        <p:cNvPr id="290" name="Shape 290"/>
         <p:cNvGrpSpPr/>
         <p:nvPr/>
       </p:nvGrpSpPr>
@@ -2814,7 +2814,7 @@
       </p:grpSpPr>
       <p:sp>
         <p:nvSpPr>
-          <p:cNvPr id="292" name="Google Shape;292;g23985d0d2d4_0_43:notes"/>
+          <p:cNvPr id="291" name="Google Shape;291;g23985d0d2d4_0_43:notes"/>
           <p:cNvSpPr/>
           <p:nvPr>
             <p:ph idx="2" type="sldImg"/>
@@ -2849,7 +2849,7 @@
       </p:sp>
       <p:sp>
         <p:nvSpPr>
-          <p:cNvPr id="293" name="Google Shape;293;g23985d0d2d4_0_43:notes"/>
+          <p:cNvPr id="292" name="Google Shape;292;g23985d0d2d4_0_43:notes"/>
           <p:cNvSpPr txBox="1"/>
           <p:nvPr>
             <p:ph idx="1" type="body"/>
@@ -2998,7 +2998,7 @@
   <p:cSld>
     <p:spTree>
       <p:nvGrpSpPr>
-        <p:cNvPr id="298" name="Shape 298"/>
+        <p:cNvPr id="297" name="Shape 297"/>
         <p:cNvGrpSpPr/>
         <p:nvPr/>
       </p:nvGrpSpPr>
@@ -3012,7 +3012,7 @@
       </p:grpSpPr>
       <p:sp>
         <p:nvSpPr>
-          <p:cNvPr id="299" name="Google Shape;299;g23985d0d2d4_0_82:notes"/>
+          <p:cNvPr id="298" name="Google Shape;298;g23985d0d2d4_0_82:notes"/>
           <p:cNvSpPr/>
           <p:nvPr>
             <p:ph idx="2" type="sldImg"/>
@@ -3047,7 +3047,7 @@
       </p:sp>
       <p:sp>
         <p:nvSpPr>
-          <p:cNvPr id="300" name="Google Shape;300;g23985d0d2d4_0_82:notes"/>
+          <p:cNvPr id="299" name="Google Shape;299;g23985d0d2d4_0_82:notes"/>
           <p:cNvSpPr txBox="1"/>
           <p:nvPr>
             <p:ph idx="1" type="body"/>
@@ -3309,7 +3309,7 @@
       </p:grpSpPr>
       <p:sp>
         <p:nvSpPr>
-          <p:cNvPr id="124" name="Google Shape;124;g39c147b832b_0_0:notes"/>
+          <p:cNvPr id="124" name="Google Shape;124;g396f953ff6f_0_48:notes"/>
           <p:cNvSpPr/>
           <p:nvPr>
             <p:ph idx="2" type="sldImg"/>
@@ -3344,7 +3344,7 @@
       </p:sp>
       <p:sp>
         <p:nvSpPr>
-          <p:cNvPr id="125" name="Google Shape;125;g39c147b832b_0_0:notes"/>
+          <p:cNvPr id="125" name="Google Shape;125;g396f953ff6f_0_48:notes"/>
           <p:cNvSpPr txBox="1"/>
           <p:nvPr>
             <p:ph idx="1" type="body"/>
@@ -11467,7 +11467,7 @@
             <a:tbl>
               <a:tblPr>
                 <a:noFill/>
-                <a:tableStyleId>{AB67F2C7-E277-495E-AD0F-626B15EC63A6}</a:tableStyleId>
+                <a:tableStyleId>{7EA05E9F-FED0-4B2F-B344-BC6183A9FCCF}</a:tableStyleId>
               </a:tblPr>
               <a:tblGrid>
                 <a:gridCol w="1432550"/>
@@ -13386,7 +13386,7 @@
             <a:tbl>
               <a:tblPr>
                 <a:noFill/>
-                <a:tableStyleId>{AB67F2C7-E277-495E-AD0F-626B15EC63A6}</a:tableStyleId>
+                <a:tableStyleId>{7EA05E9F-FED0-4B2F-B344-BC6183A9FCCF}</a:tableStyleId>
               </a:tblPr>
               <a:tblGrid>
                 <a:gridCol w="1432550"/>
@@ -18707,7 +18707,7 @@
           </a:prstGeom>
         </p:spPr>
         <p:txBody>
-          <a:bodyPr anchorCtr="0" anchor="ctr" bIns="91425" lIns="274300" spcFirstLastPara="1" rIns="91425" wrap="square" tIns="91425">
+          <a:bodyPr anchorCtr="0" anchor="ctr" bIns="0" lIns="274300" spcFirstLastPara="1" rIns="0" wrap="square" tIns="0">
             <a:noAutofit/>
           </a:bodyPr>
           <a:lstStyle/>
@@ -18723,11 +18723,93 @@
             </a:pPr>
             <a:r>
               <a:rPr lang="en"/>
-              <a:t>Course Management vs. Exam Registration</a:t>
-            </a:r>
+              <a:t>No Oral or Written Exam [1] [2]</a:t>
+            </a:r>
+            <a:endParaRPr/>
+          </a:p>
+        </p:txBody>
+      </p:sp>
+      <p:pic>
+        <p:nvPicPr>
+          <p:cNvPr id="245" name="Google Shape;245;p36"/>
+          <p:cNvPicPr preferRelativeResize="0"/>
+          <p:nvPr/>
+        </p:nvPicPr>
+        <p:blipFill>
+          <a:blip r:embed="rId3">
+            <a:alphaModFix/>
+          </a:blip>
+          <a:stretch>
+            <a:fillRect/>
+          </a:stretch>
+        </p:blipFill>
+        <p:spPr>
+          <a:xfrm>
+            <a:off x="2743200" y="914400"/>
+            <a:ext cx="3657601" cy="3649471"/>
+          </a:xfrm>
+          <a:prstGeom prst="rect">
+            <a:avLst/>
+          </a:prstGeom>
+          <a:noFill/>
+          <a:ln>
+            <a:noFill/>
+          </a:ln>
+        </p:spPr>
+      </p:pic>
+      <p:sp>
+        <p:nvSpPr>
+          <p:cNvPr id="246" name="Google Shape;246;p36"/>
+          <p:cNvSpPr txBox="1"/>
+          <p:nvPr/>
+        </p:nvSpPr>
+        <p:spPr>
+          <a:xfrm>
+            <a:off x="0" y="4233672"/>
+            <a:ext cx="9144000" cy="914400"/>
+          </a:xfrm>
+          <a:prstGeom prst="rect">
+            <a:avLst/>
+          </a:prstGeom>
+          <a:noFill/>
+          <a:ln>
+            <a:noFill/>
+          </a:ln>
+        </p:spPr>
+        <p:txBody>
+          <a:bodyPr anchorCtr="0" anchor="b" bIns="91425" lIns="91425" spcFirstLastPara="1" rIns="91425" wrap="square" tIns="91425">
+            <a:noAutofit/>
+          </a:bodyPr>
+          <a:lstStyle/>
+          <a:p>
+            <a:pPr indent="0" lvl="0" marL="0" rtl="0" algn="l">
+              <a:spcBef>
+                <a:spcPts val="0"/>
+              </a:spcBef>
+              <a:spcAft>
+                <a:spcPts val="0"/>
+              </a:spcAft>
+              <a:buNone/>
+            </a:pPr>
             <a:r>
               <a:rPr lang="en"/>
-              <a:t> [1]</a:t>
+              <a:t>[1] If both you and we don’t want to</a:t>
+            </a:r>
+            <a:endParaRPr/>
+          </a:p>
+          <a:p>
+            <a:pPr indent="0" lvl="0" marL="0" rtl="0" algn="l">
+              <a:spcBef>
+                <a:spcPts val="0"/>
+              </a:spcBef>
+              <a:spcAft>
+                <a:spcPts val="0"/>
+              </a:spcAft>
+              <a:buNone/>
+            </a:pPr>
+            <a:r>
+              <a:rPr lang="en"/>
+              <a:t>[2] You still have to register for the course</a:t>
             </a:r>
             <a:endParaRPr/>
           </a:p>
@@ -18735,184 +18817,7 @@
       </p:sp>
       <p:sp>
         <p:nvSpPr>
-          <p:cNvPr id="245" name="Google Shape;245;p36"/>
-          <p:cNvSpPr txBox="1"/>
-          <p:nvPr>
-            <p:ph idx="1" type="body"/>
-          </p:nvPr>
-        </p:nvSpPr>
-        <p:spPr>
-          <a:xfrm>
-            <a:off x="274320" y="914400"/>
-            <a:ext cx="8595300" cy="4114800"/>
-          </a:xfrm>
-          <a:prstGeom prst="rect">
-            <a:avLst/>
-          </a:prstGeom>
-        </p:spPr>
-        <p:txBody>
-          <a:bodyPr anchorCtr="0" anchor="t" bIns="0" lIns="0" spcFirstLastPara="1" rIns="0" wrap="square" tIns="0">
-            <a:noAutofit/>
-          </a:bodyPr>
-          <a:lstStyle/>
-          <a:p>
-            <a:pPr indent="0" lvl="0" marL="0" rtl="0" algn="l">
-              <a:spcBef>
-                <a:spcPts val="0"/>
-              </a:spcBef>
-              <a:spcAft>
-                <a:spcPts val="0"/>
-              </a:spcAft>
-              <a:buClr>
-                <a:schemeClr val="dk1"/>
-              </a:buClr>
-              <a:buSzPts val="1100"/>
-              <a:buFont typeface="Arial"/>
-              <a:buNone/>
-            </a:pPr>
-            <a:r>
-              <a:rPr lang="en"/>
-              <a:t>AMOS course management</a:t>
-            </a:r>
-            <a:endParaRPr/>
-          </a:p>
-          <a:p>
-            <a:pPr indent="-342900" lvl="0" marL="457200" rtl="0" algn="l">
-              <a:spcBef>
-                <a:spcPts val="1200"/>
-              </a:spcBef>
-              <a:spcAft>
-                <a:spcPts val="0"/>
-              </a:spcAft>
-              <a:buSzPts val="1800"/>
-              <a:buChar char="●"/>
-            </a:pPr>
-            <a:r>
-              <a:rPr lang="en" u="sng">
-                <a:solidFill>
-                  <a:schemeClr val="hlink"/>
-                </a:solidFill>
-                <a:hlinkClick r:id="rId3"/>
-              </a:rPr>
-              <a:t>https://moo.uni1.de</a:t>
-            </a:r>
-            <a:r>
-              <a:rPr lang="en"/>
-              <a:t> (Uni1 Moodle)</a:t>
-            </a:r>
-            <a:endParaRPr/>
-          </a:p>
-          <a:p>
-            <a:pPr indent="0" lvl="0" marL="0" rtl="0" algn="l">
-              <a:spcBef>
-                <a:spcPts val="1200"/>
-              </a:spcBef>
-              <a:spcAft>
-                <a:spcPts val="0"/>
-              </a:spcAft>
-              <a:buClr>
-                <a:schemeClr val="dk1"/>
-              </a:buClr>
-              <a:buSzPts val="1100"/>
-              <a:buFont typeface="Arial"/>
-              <a:buNone/>
-            </a:pPr>
-            <a:r>
-              <a:rPr lang="en"/>
-              <a:t>University course management</a:t>
-            </a:r>
-            <a:endParaRPr/>
-          </a:p>
-          <a:p>
-            <a:pPr indent="-342900" lvl="0" marL="457200" rtl="0" algn="l">
-              <a:spcBef>
-                <a:spcPts val="1200"/>
-              </a:spcBef>
-              <a:spcAft>
-                <a:spcPts val="0"/>
-              </a:spcAft>
-              <a:buSzPts val="1800"/>
-              <a:buChar char="●"/>
-            </a:pPr>
-            <a:r>
-              <a:rPr lang="en"/>
-              <a:t>StudOn (FAU) | ISIS (TUB) | CM (FUB)</a:t>
-            </a:r>
-            <a:endParaRPr/>
-          </a:p>
-          <a:p>
-            <a:pPr indent="0" lvl="0" marL="0" rtl="0" algn="l">
-              <a:spcBef>
-                <a:spcPts val="1200"/>
-              </a:spcBef>
-              <a:spcAft>
-                <a:spcPts val="0"/>
-              </a:spcAft>
-              <a:buClr>
-                <a:schemeClr val="dk1"/>
-              </a:buClr>
-              <a:buSzPts val="1100"/>
-              <a:buFont typeface="Arial"/>
-              <a:buNone/>
-            </a:pPr>
-            <a:r>
-              <a:rPr lang="en"/>
-              <a:t>Exam registration (later)</a:t>
-            </a:r>
-            <a:endParaRPr/>
-          </a:p>
-          <a:p>
-            <a:pPr indent="-342900" lvl="0" marL="457200" rtl="0" algn="l">
-              <a:spcBef>
-                <a:spcPts val="1200"/>
-              </a:spcBef>
-              <a:spcAft>
-                <a:spcPts val="0"/>
-              </a:spcAft>
-              <a:buSzPts val="1800"/>
-              <a:buChar char="●"/>
-            </a:pPr>
-            <a:r>
-              <a:rPr lang="en"/>
-              <a:t>Campo (FAU) | MOSES (TUB)</a:t>
-            </a:r>
-            <a:endParaRPr/>
-          </a:p>
-          <a:p>
-            <a:pPr indent="0" lvl="0" marL="0" rtl="0" algn="l">
-              <a:spcBef>
-                <a:spcPts val="1200"/>
-              </a:spcBef>
-              <a:spcAft>
-                <a:spcPts val="0"/>
-              </a:spcAft>
-              <a:buNone/>
-            </a:pPr>
-            <a:r>
-              <a:t/>
-            </a:r>
-            <a:endParaRPr/>
-          </a:p>
-          <a:p>
-            <a:pPr indent="0" lvl="0" marL="0" rtl="0" algn="l">
-              <a:spcBef>
-                <a:spcPts val="1200"/>
-              </a:spcBef>
-              <a:spcAft>
-                <a:spcPts val="1200"/>
-              </a:spcAft>
-              <a:buNone/>
-            </a:pPr>
-            <a:r>
-              <a:t/>
-            </a:r>
-            <a:endParaRPr/>
-          </a:p>
-        </p:txBody>
-      </p:sp>
-      <p:sp>
-        <p:nvSpPr>
-          <p:cNvPr id="246" name="Google Shape;246;p36"/>
+          <p:cNvPr id="247" name="Google Shape;247;p36"/>
           <p:cNvSpPr txBox="1"/>
           <p:nvPr>
             <p:ph idx="12" type="sldNum"/>
@@ -18978,48 +18883,6 @@
             <a:r>
               <a:rPr b="0" lang="en" sz="900"/>
               <a:t> </a:t>
-            </a:r>
-            <a:endParaRPr b="0" sz="900"/>
-          </a:p>
-        </p:txBody>
-      </p:sp>
-      <p:sp>
-        <p:nvSpPr>
-          <p:cNvPr id="247" name="Google Shape;247;p36"/>
-          <p:cNvSpPr txBox="1"/>
-          <p:nvPr/>
-        </p:nvSpPr>
-        <p:spPr>
-          <a:xfrm>
-            <a:off x="0" y="4233672"/>
-            <a:ext cx="7315200" cy="914400"/>
-          </a:xfrm>
-          <a:prstGeom prst="rect">
-            <a:avLst/>
-          </a:prstGeom>
-          <a:noFill/>
-          <a:ln>
-            <a:noFill/>
-          </a:ln>
-        </p:spPr>
-        <p:txBody>
-          <a:bodyPr anchorCtr="0" anchor="b" bIns="91425" lIns="91425" spcFirstLastPara="1" rIns="91425" wrap="square" tIns="91425">
-            <a:noAutofit/>
-          </a:bodyPr>
-          <a:lstStyle/>
-          <a:p>
-            <a:pPr indent="0" lvl="0" marL="0" rtl="0" algn="l">
-              <a:spcBef>
-                <a:spcPts val="0"/>
-              </a:spcBef>
-              <a:spcAft>
-                <a:spcPts val="0"/>
-              </a:spcAft>
-              <a:buNone/>
-            </a:pPr>
-            <a:r>
-              <a:rPr lang="en"/>
-              <a:t>[1] German: Prüfungsanmeldung</a:t>
             </a:r>
             <a:endParaRPr/>
           </a:p>
@@ -19068,7 +18931,7 @@
           </a:prstGeom>
         </p:spPr>
         <p:txBody>
-          <a:bodyPr anchorCtr="0" anchor="ctr" bIns="0" lIns="274300" spcFirstLastPara="1" rIns="0" wrap="square" tIns="0">
+          <a:bodyPr anchorCtr="0" anchor="ctr" bIns="91425" lIns="274300" spcFirstLastPara="1" rIns="91425" wrap="square" tIns="91425">
             <a:noAutofit/>
           </a:bodyPr>
           <a:lstStyle/>
@@ -19084,50 +18947,22 @@
             </a:pPr>
             <a:r>
               <a:rPr lang="en"/>
-              <a:t>No Oral or Written Exam [1] [2]</a:t>
+              <a:t>Course Language [1]</a:t>
             </a:r>
             <a:endParaRPr/>
           </a:p>
         </p:txBody>
       </p:sp>
-      <p:pic>
-        <p:nvPicPr>
-          <p:cNvPr id="253" name="Google Shape;253;p37"/>
-          <p:cNvPicPr preferRelativeResize="0"/>
-          <p:nvPr/>
-        </p:nvPicPr>
-        <p:blipFill>
-          <a:blip r:embed="rId3">
-            <a:alphaModFix/>
-          </a:blip>
-          <a:stretch>
-            <a:fillRect/>
-          </a:stretch>
-        </p:blipFill>
-        <p:spPr>
-          <a:xfrm>
-            <a:off x="2743200" y="914400"/>
-            <a:ext cx="3657601" cy="3649471"/>
-          </a:xfrm>
-          <a:prstGeom prst="rect">
-            <a:avLst/>
-          </a:prstGeom>
-          <a:noFill/>
-          <a:ln>
-            <a:noFill/>
-          </a:ln>
-        </p:spPr>
-      </p:pic>
       <p:sp>
         <p:nvSpPr>
-          <p:cNvPr id="254" name="Google Shape;254;p37"/>
+          <p:cNvPr id="253" name="Google Shape;253;p37"/>
           <p:cNvSpPr txBox="1"/>
           <p:nvPr/>
         </p:nvSpPr>
         <p:spPr>
           <a:xfrm>
-            <a:off x="0" y="4233672"/>
-            <a:ext cx="9144000" cy="914400"/>
+            <a:off x="0" y="4229100"/>
+            <a:ext cx="7315200" cy="914400"/>
           </a:xfrm>
           <a:prstGeom prst="rect">
             <a:avLst/>
@@ -19154,10 +18989,47 @@
             </a:pPr>
             <a:r>
               <a:rPr lang="en"/>
-              <a:t>[1] If both you and we don’t want to</a:t>
+              <a:t>[1] See </a:t>
+            </a:r>
+            <a:r>
+              <a:rPr lang="en" u="sng">
+                <a:solidFill>
+                  <a:schemeClr val="hlink"/>
+                </a:solidFill>
+                <a:hlinkClick r:id="rId3"/>
+              </a:rPr>
+              <a:t>https://oss.cs.fau.de/2012/03/10/english-or-german-deutsch-oder-englisch/</a:t>
+            </a:r>
+            <a:r>
+              <a:rPr lang="en"/>
+              <a:t> </a:t>
             </a:r>
             <a:endParaRPr/>
           </a:p>
+        </p:txBody>
+      </p:sp>
+      <p:sp>
+        <p:nvSpPr>
+          <p:cNvPr id="254" name="Google Shape;254;p37"/>
+          <p:cNvSpPr txBox="1"/>
+          <p:nvPr>
+            <p:ph idx="1" type="body"/>
+          </p:nvPr>
+        </p:nvSpPr>
+        <p:spPr>
+          <a:xfrm>
+            <a:off x="274320" y="914400"/>
+            <a:ext cx="8595300" cy="4114800"/>
+          </a:xfrm>
+          <a:prstGeom prst="rect">
+            <a:avLst/>
+          </a:prstGeom>
+        </p:spPr>
+        <p:txBody>
+          <a:bodyPr anchorCtr="0" anchor="t" bIns="0" lIns="0" spcFirstLastPara="1" rIns="0" wrap="square" tIns="0">
+            <a:noAutofit/>
+          </a:bodyPr>
+          <a:lstStyle/>
           <a:p>
             <a:pPr indent="0" lvl="0" marL="0" rtl="0" algn="l">
               <a:spcBef>
@@ -19166,11 +19038,120 @@
               <a:spcAft>
                 <a:spcPts val="0"/>
               </a:spcAft>
+              <a:buClr>
+                <a:schemeClr val="dk1"/>
+              </a:buClr>
+              <a:buSzPts val="1100"/>
+              <a:buFont typeface="Arial"/>
               <a:buNone/>
             </a:pPr>
             <a:r>
               <a:rPr lang="en"/>
-              <a:t>[2] You still have to register for the course</a:t>
+              <a:t>Class</a:t>
+            </a:r>
+            <a:endParaRPr/>
+          </a:p>
+          <a:p>
+            <a:pPr indent="-342900" lvl="0" marL="457200" rtl="0" algn="l">
+              <a:spcBef>
+                <a:spcPts val="1200"/>
+              </a:spcBef>
+              <a:spcAft>
+                <a:spcPts val="0"/>
+              </a:spcAft>
+              <a:buSzPts val="1800"/>
+              <a:buChar char="●"/>
+            </a:pPr>
+            <a:r>
+              <a:rPr lang="en"/>
+              <a:t>Lecturer: English</a:t>
+            </a:r>
+            <a:endParaRPr/>
+          </a:p>
+          <a:p>
+            <a:pPr indent="-342900" lvl="0" marL="457200" rtl="0" algn="l">
+              <a:spcBef>
+                <a:spcPts val="0"/>
+              </a:spcBef>
+              <a:spcAft>
+                <a:spcPts val="0"/>
+              </a:spcAft>
+              <a:buSzPts val="1800"/>
+              <a:buChar char="●"/>
+            </a:pPr>
+            <a:r>
+              <a:rPr lang="en"/>
+              <a:t>Student: Choice of German or English</a:t>
+            </a:r>
+            <a:endParaRPr/>
+          </a:p>
+          <a:p>
+            <a:pPr indent="0" lvl="0" marL="0" rtl="0" algn="l">
+              <a:spcBef>
+                <a:spcPts val="1200"/>
+              </a:spcBef>
+              <a:spcAft>
+                <a:spcPts val="0"/>
+              </a:spcAft>
+              <a:buClr>
+                <a:schemeClr val="dk1"/>
+              </a:buClr>
+              <a:buSzPts val="1100"/>
+              <a:buFont typeface="Arial"/>
+              <a:buNone/>
+            </a:pPr>
+            <a:r>
+              <a:rPr lang="en"/>
+              <a:t>Project</a:t>
+            </a:r>
+            <a:endParaRPr/>
+          </a:p>
+          <a:p>
+            <a:pPr indent="-342900" lvl="0" marL="457200" rtl="0" algn="l">
+              <a:spcBef>
+                <a:spcPts val="1200"/>
+              </a:spcBef>
+              <a:spcAft>
+                <a:spcPts val="0"/>
+              </a:spcAft>
+              <a:buSzPts val="1800"/>
+              <a:buChar char="●"/>
+            </a:pPr>
+            <a:r>
+              <a:rPr lang="en"/>
+              <a:t>Instructor: English</a:t>
+            </a:r>
+            <a:endParaRPr/>
+          </a:p>
+          <a:p>
+            <a:pPr indent="-342900" lvl="0" marL="457200" rtl="0" algn="l">
+              <a:spcBef>
+                <a:spcPts val="0"/>
+              </a:spcBef>
+              <a:spcAft>
+                <a:spcPts val="0"/>
+              </a:spcAft>
+              <a:buSzPts val="1800"/>
+              <a:buChar char="●"/>
+            </a:pPr>
+            <a:r>
+              <a:rPr lang="en"/>
+              <a:t>Team: Choice of German or English</a:t>
+            </a:r>
+            <a:endParaRPr/>
+          </a:p>
+          <a:p>
+            <a:pPr indent="0" lvl="0" marL="0" rtl="0" algn="l">
+              <a:spcBef>
+                <a:spcPts val="1200"/>
+              </a:spcBef>
+              <a:spcAft>
+                <a:spcPts val="1200"/>
+              </a:spcAft>
+              <a:buNone/>
+            </a:pPr>
+            <a:r>
+              <a:t/>
             </a:r>
             <a:endParaRPr/>
           </a:p>
@@ -19245,7 +19226,7 @@
               <a:rPr b="0" lang="en" sz="900"/>
               <a:t> </a:t>
             </a:r>
-            <a:endParaRPr/>
+            <a:endParaRPr b="0" sz="900"/>
           </a:p>
         </p:txBody>
       </p:sp>
@@ -19279,6 +19260,196 @@
           <p:cNvPr id="260" name="Google Shape;260;p38"/>
           <p:cNvSpPr txBox="1"/>
           <p:nvPr>
+            <p:ph idx="1" type="body"/>
+          </p:nvPr>
+        </p:nvSpPr>
+        <p:spPr>
+          <a:xfrm>
+            <a:off x="274320" y="914400"/>
+            <a:ext cx="8595300" cy="4114800"/>
+          </a:xfrm>
+          <a:prstGeom prst="rect">
+            <a:avLst/>
+          </a:prstGeom>
+        </p:spPr>
+        <p:txBody>
+          <a:bodyPr anchorCtr="0" anchor="t" bIns="0" lIns="0" spcFirstLastPara="1" rIns="0" wrap="square" tIns="0">
+            <a:noAutofit/>
+          </a:bodyPr>
+          <a:lstStyle/>
+          <a:p>
+            <a:pPr indent="-342900" lvl="0" marL="457200" rtl="0" algn="l">
+              <a:spcBef>
+                <a:spcPts val="0"/>
+              </a:spcBef>
+              <a:spcAft>
+                <a:spcPts val="0"/>
+              </a:spcAft>
+              <a:buSzPts val="1800"/>
+              <a:buAutoNum type="arabicPeriod"/>
+            </a:pPr>
+            <a:r>
+              <a:rPr lang="en"/>
+              <a:t>Course registration</a:t>
+            </a:r>
+            <a:endParaRPr/>
+          </a:p>
+          <a:p>
+            <a:pPr indent="-317500" lvl="1" marL="914400" rtl="0" algn="l">
+              <a:spcBef>
+                <a:spcPts val="0"/>
+              </a:spcBef>
+              <a:spcAft>
+                <a:spcPts val="0"/>
+              </a:spcAft>
+              <a:buSzPts val="1400"/>
+              <a:buAutoNum type="alphaLcPeriod"/>
+            </a:pPr>
+            <a:r>
+              <a:rPr lang="en"/>
+              <a:t>Sign-up on StudOn (FAU) | ISIS (TUB) | CM (FUB) / open now</a:t>
+            </a:r>
+            <a:endParaRPr/>
+          </a:p>
+          <a:p>
+            <a:pPr indent="-317500" lvl="1" marL="914400" rtl="0" algn="l">
+              <a:spcBef>
+                <a:spcPts val="0"/>
+              </a:spcBef>
+              <a:spcAft>
+                <a:spcPts val="0"/>
+              </a:spcAft>
+              <a:buSzPts val="1400"/>
+              <a:buAutoNum type="alphaLcPeriod"/>
+            </a:pPr>
+            <a:r>
+              <a:rPr lang="en"/>
+              <a:t>Needed to get your id for matching you on Campo</a:t>
+            </a:r>
+            <a:endParaRPr/>
+          </a:p>
+          <a:p>
+            <a:pPr indent="-342900" lvl="0" marL="457200" rtl="0" algn="l">
+              <a:spcBef>
+                <a:spcPts val="0"/>
+              </a:spcBef>
+              <a:spcAft>
+                <a:spcPts val="0"/>
+              </a:spcAft>
+              <a:buSzPts val="1800"/>
+              <a:buAutoNum type="arabicPeriod"/>
+            </a:pPr>
+            <a:r>
+              <a:rPr lang="en"/>
+              <a:t>Course management</a:t>
+            </a:r>
+            <a:endParaRPr/>
+          </a:p>
+          <a:p>
+            <a:pPr indent="-317500" lvl="1" marL="914400" rtl="0" algn="l">
+              <a:spcBef>
+                <a:spcPts val="0"/>
+              </a:spcBef>
+              <a:spcAft>
+                <a:spcPts val="0"/>
+              </a:spcAft>
+              <a:buSzPts val="1400"/>
+              <a:buAutoNum type="alphaLcPeriod"/>
+            </a:pPr>
+            <a:r>
+              <a:rPr lang="en"/>
+              <a:t>Sign-up on the Uni1 Moodle (</a:t>
+            </a:r>
+            <a:r>
+              <a:rPr lang="en" u="sng">
+                <a:solidFill>
+                  <a:schemeClr val="hlink"/>
+                </a:solidFill>
+                <a:hlinkClick r:id="rId3"/>
+              </a:rPr>
+              <a:t>https://moo.uni1.de</a:t>
+            </a:r>
+            <a:r>
+              <a:rPr lang="en"/>
+              <a:t>) / open now</a:t>
+            </a:r>
+            <a:endParaRPr/>
+          </a:p>
+          <a:p>
+            <a:pPr indent="-317500" lvl="1" marL="914400" rtl="0" algn="l">
+              <a:spcBef>
+                <a:spcPts val="0"/>
+              </a:spcBef>
+              <a:spcAft>
+                <a:spcPts val="0"/>
+              </a:spcAft>
+              <a:buSzPts val="1400"/>
+              <a:buAutoNum type="alphaLcPeriod"/>
+            </a:pPr>
+            <a:r>
+              <a:rPr lang="en"/>
+              <a:t>Use your university email address; if not no grade</a:t>
+            </a:r>
+            <a:endParaRPr/>
+          </a:p>
+          <a:p>
+            <a:pPr indent="-342900" lvl="0" marL="457200" rtl="0" algn="l">
+              <a:spcBef>
+                <a:spcPts val="0"/>
+              </a:spcBef>
+              <a:spcAft>
+                <a:spcPts val="0"/>
+              </a:spcAft>
+              <a:buSzPts val="1800"/>
+              <a:buAutoNum type="arabicPeriod"/>
+            </a:pPr>
+            <a:r>
+              <a:rPr lang="en"/>
+              <a:t>Exam registration</a:t>
+            </a:r>
+            <a:endParaRPr/>
+          </a:p>
+          <a:p>
+            <a:pPr indent="-317500" lvl="1" marL="914400" rtl="0" algn="l">
+              <a:spcBef>
+                <a:spcPts val="0"/>
+              </a:spcBef>
+              <a:spcAft>
+                <a:spcPts val="0"/>
+              </a:spcAft>
+              <a:buSzPts val="1400"/>
+              <a:buAutoNum type="alphaLcPeriod"/>
+            </a:pPr>
+            <a:r>
+              <a:rPr lang="en"/>
+              <a:t>Sign-up on Campo (FAU) | MOSES (TUB) / opens later</a:t>
+            </a:r>
+            <a:endParaRPr/>
+          </a:p>
+          <a:p>
+            <a:pPr indent="-317500" lvl="1" marL="914400" rtl="0" algn="l">
+              <a:spcBef>
+                <a:spcPts val="0"/>
+              </a:spcBef>
+              <a:spcAft>
+                <a:spcPts val="0"/>
+              </a:spcAft>
+              <a:buSzPts val="1400"/>
+              <a:buAutoNum type="alphaLcPeriod"/>
+            </a:pPr>
+            <a:r>
+              <a:rPr lang="en"/>
+              <a:t>No exam registration no grade</a:t>
+            </a:r>
+            <a:endParaRPr/>
+          </a:p>
+        </p:txBody>
+      </p:sp>
+      <p:sp>
+        <p:nvSpPr>
+          <p:cNvPr id="261" name="Google Shape;261;p38"/>
+          <p:cNvSpPr txBox="1"/>
+          <p:nvPr>
             <p:ph type="title"/>
           </p:nvPr>
         </p:nvSpPr>
@@ -19308,7 +19479,7 @@
             </a:pPr>
             <a:r>
               <a:rPr lang="en"/>
-              <a:t>Course Language [1]</a:t>
+              <a:t>The Three Steps to Proper Registration</a:t>
             </a:r>
             <a:endParaRPr/>
           </a:p>
@@ -19316,22 +19487,20 @@
       </p:sp>
       <p:sp>
         <p:nvSpPr>
-          <p:cNvPr id="261" name="Google Shape;261;p38"/>
+          <p:cNvPr id="262" name="Google Shape;262;p38"/>
           <p:cNvSpPr txBox="1"/>
-          <p:nvPr/>
+          <p:nvPr>
+            <p:ph idx="12" type="sldNum"/>
+          </p:nvPr>
         </p:nvSpPr>
         <p:spPr>
           <a:xfrm>
-            <a:off x="0" y="4229100"/>
-            <a:ext cx="7315200" cy="914400"/>
+            <a:off x="7315202" y="4416550"/>
+            <a:ext cx="1828800" cy="731400"/>
           </a:xfrm>
           <a:prstGeom prst="rect">
             <a:avLst/>
           </a:prstGeom>
-          <a:noFill/>
-          <a:ln>
-            <a:noFill/>
-          </a:ln>
         </p:spPr>
         <p:txBody>
           <a:bodyPr anchorCtr="0" anchor="b" bIns="91425" lIns="91425" spcFirstLastPara="1" rIns="91425" wrap="square" tIns="91425">
@@ -19339,31 +19508,116 @@
           </a:bodyPr>
           <a:lstStyle/>
           <a:p>
-            <a:pPr indent="0" lvl="0" marL="0" rtl="0" algn="l">
-              <a:spcBef>
-                <a:spcPts val="0"/>
-              </a:spcBef>
-              <a:spcAft>
-                <a:spcPts val="0"/>
-              </a:spcAft>
-              <a:buNone/>
-            </a:pPr>
-            <a:r>
+            <a:pPr indent="0" lvl="0" marL="0" rtl="0" algn="r">
+              <a:spcBef>
+                <a:spcPts val="0"/>
+              </a:spcBef>
+              <a:spcAft>
+                <a:spcPts val="0"/>
+              </a:spcAft>
+              <a:buNone/>
+            </a:pPr>
+            <a:fld id="{00000000-1234-1234-1234-123412341234}" type="slidenum">
               <a:rPr lang="en"/>
-              <a:t>[1] See </a:t>
-            </a:r>
-            <a:r>
-              <a:rPr lang="en" u="sng">
+              <a:t>‹#›</a:t>
+            </a:fld>
+            <a:endParaRPr/>
+          </a:p>
+          <a:p>
+            <a:pPr indent="0" lvl="0" marL="0" rtl="0" algn="r">
+              <a:spcBef>
+                <a:spcPts val="0"/>
+              </a:spcBef>
+              <a:spcAft>
+                <a:spcPts val="0"/>
+              </a:spcAft>
+              <a:buNone/>
+            </a:pPr>
+            <a:r>
+              <a:rPr b="0" lang="en" sz="900" u="sng">
                 <a:solidFill>
                   <a:schemeClr val="hlink"/>
                 </a:solidFill>
-                <a:hlinkClick r:id="rId3"/>
+                <a:hlinkClick r:id="rId4"/>
               </a:rPr>
-              <a:t>https://oss.cs.fau.de/2012/03/10/english-or-german-deutsch-oder-englisch/</a:t>
-            </a:r>
+              <a:t>https://oss.cs.fau.de</a:t>
+            </a:r>
+            <a:r>
+              <a:rPr b="0" lang="en" sz="900">
+                <a:solidFill>
+                  <a:schemeClr val="dk2"/>
+                </a:solidFill>
+              </a:rPr>
+              <a:t> </a:t>
+            </a:r>
+            <a:endParaRPr b="0" sz="900">
+              <a:solidFill>
+                <a:schemeClr val="dk2"/>
+              </a:solidFill>
+            </a:endParaRPr>
+          </a:p>
+        </p:txBody>
+      </p:sp>
+    </p:spTree>
+  </p:cSld>
+  <p:clrMapOvr>
+    <a:masterClrMapping/>
+  </p:clrMapOvr>
+</p:sld>
+</file>
+
+<file path=ppt/slides/slide25.xml><?xml version="1.0" encoding="utf-8"?>
+<p:sld xmlns:a="http://schemas.openxmlformats.org/drawingml/2006/main" xmlns:r="http://schemas.openxmlformats.org/officeDocument/2006/relationships" xmlns:mc="http://schemas.openxmlformats.org/markup-compatibility/2006" xmlns:mv="urn:schemas-microsoft-com:mac:vml" xmlns:p="http://schemas.openxmlformats.org/presentationml/2006/main" xmlns:c="http://schemas.openxmlformats.org/drawingml/2006/chart" xmlns:dgm="http://schemas.openxmlformats.org/drawingml/2006/diagram" xmlns:o="urn:schemas-microsoft-com:office:office" xmlns:v="urn:schemas-microsoft-com:vml" xmlns:pvml="urn:schemas-microsoft-com:office:powerpoint" xmlns:com="http://schemas.openxmlformats.org/drawingml/2006/compatibility" xmlns:p14="http://schemas.microsoft.com/office/powerpoint/2010/main" xmlns:p15="http://schemas.microsoft.com/office/powerpoint/2012/main" xmlns:ahyp="http://schemas.microsoft.com/office/drawing/2018/hyperlinkcolor">
+  <p:cSld>
+    <p:spTree>
+      <p:nvGrpSpPr>
+        <p:cNvPr id="266" name="Shape 266"/>
+        <p:cNvGrpSpPr/>
+        <p:nvPr/>
+      </p:nvGrpSpPr>
+      <p:grpSpPr>
+        <a:xfrm>
+          <a:off x="0" y="0"/>
+          <a:ext cx="0" cy="0"/>
+          <a:chOff x="0" y="0"/>
+          <a:chExt cx="0" cy="0"/>
+        </a:xfrm>
+      </p:grpSpPr>
+      <p:sp>
+        <p:nvSpPr>
+          <p:cNvPr id="267" name="Google Shape;267;p39"/>
+          <p:cNvSpPr txBox="1"/>
+          <p:nvPr>
+            <p:ph type="title"/>
+          </p:nvPr>
+        </p:nvSpPr>
+        <p:spPr>
+          <a:xfrm>
+            <a:off x="0" y="0"/>
+            <a:ext cx="9144000" cy="685800"/>
+          </a:xfrm>
+          <a:prstGeom prst="rect">
+            <a:avLst/>
+          </a:prstGeom>
+        </p:spPr>
+        <p:txBody>
+          <a:bodyPr anchorCtr="0" anchor="ctr" bIns="91425" lIns="274300" spcFirstLastPara="1" rIns="91425" wrap="square" tIns="91425">
+            <a:noAutofit/>
+          </a:bodyPr>
+          <a:lstStyle/>
+          <a:p>
+            <a:pPr indent="0" lvl="0" marL="0" rtl="0" algn="l">
+              <a:spcBef>
+                <a:spcPts val="0"/>
+              </a:spcBef>
+              <a:spcAft>
+                <a:spcPts val="0"/>
+              </a:spcAft>
+              <a:buNone/>
+            </a:pPr>
             <a:r>
               <a:rPr lang="en"/>
-              <a:t> </a:t>
+              <a:t>Information Index</a:t>
             </a:r>
             <a:endParaRPr/>
           </a:p>
@@ -19371,7 +19625,7 @@
       </p:sp>
       <p:sp>
         <p:nvSpPr>
-          <p:cNvPr id="262" name="Google Shape;262;p38"/>
+          <p:cNvPr id="268" name="Google Shape;268;p39"/>
           <p:cNvSpPr txBox="1"/>
           <p:nvPr>
             <p:ph idx="1" type="body"/>
@@ -19399,16 +19653,15 @@
               <a:spcAft>
                 <a:spcPts val="0"/>
               </a:spcAft>
-              <a:buClr>
-                <a:schemeClr val="dk1"/>
-              </a:buClr>
-              <a:buSzPts val="1100"/>
-              <a:buFont typeface="Arial"/>
               <a:buNone/>
             </a:pPr>
             <a:r>
               <a:rPr lang="en"/>
-              <a:t>Class</a:t>
+              <a:t>I</a:t>
+            </a:r>
+            <a:r>
+              <a:rPr lang="en"/>
+              <a:t>nformation index</a:t>
             </a:r>
             <a:endParaRPr/>
           </a:p>
@@ -19425,14 +19678,43 @@
             </a:pPr>
             <a:r>
               <a:rPr lang="en"/>
-              <a:t>Lecturer: English</a:t>
+              <a:t>See </a:t>
+            </a:r>
+            <a:r>
+              <a:rPr lang="en" u="sng">
+                <a:solidFill>
+                  <a:schemeClr val="hlink"/>
+                </a:solidFill>
+                <a:hlinkClick r:id="rId3"/>
+              </a:rPr>
+              <a:t>https://amos.uni1.de</a:t>
+            </a:r>
+            <a:r>
+              <a:rPr lang="en"/>
+              <a:t>   </a:t>
             </a:r>
             <a:endParaRPr/>
           </a:p>
           <a:p>
+            <a:pPr indent="0" lvl="0" marL="0" rtl="0" algn="l">
+              <a:spcBef>
+                <a:spcPts val="1200"/>
+              </a:spcBef>
+              <a:spcAft>
+                <a:spcPts val="0"/>
+              </a:spcAft>
+              <a:buNone/>
+            </a:pPr>
+            <a:r>
+              <a:rPr lang="en"/>
+              <a:t>Course schedule</a:t>
+            </a:r>
+            <a:endParaRPr/>
+          </a:p>
+          <a:p>
             <a:pPr indent="-342900" lvl="0" marL="457200" rtl="0" algn="l">
               <a:spcBef>
-                <a:spcPts val="0"/>
+                <a:spcPts val="1200"/>
               </a:spcBef>
               <a:spcAft>
                 <a:spcPts val="0"/>
@@ -19442,62 +19724,7 @@
             </a:pPr>
             <a:r>
               <a:rPr lang="en"/>
-              <a:t>Student: Choice of German or English</a:t>
-            </a:r>
-            <a:endParaRPr/>
-          </a:p>
-          <a:p>
-            <a:pPr indent="0" lvl="0" marL="0" rtl="0" algn="l">
-              <a:spcBef>
-                <a:spcPts val="1200"/>
-              </a:spcBef>
-              <a:spcAft>
-                <a:spcPts val="0"/>
-              </a:spcAft>
-              <a:buClr>
-                <a:schemeClr val="dk1"/>
-              </a:buClr>
-              <a:buSzPts val="1100"/>
-              <a:buFont typeface="Arial"/>
-              <a:buNone/>
-            </a:pPr>
-            <a:r>
-              <a:rPr lang="en"/>
-              <a:t>Project</a:t>
-            </a:r>
-            <a:endParaRPr/>
-          </a:p>
-          <a:p>
-            <a:pPr indent="-342900" lvl="0" marL="457200" rtl="0" algn="l">
-              <a:spcBef>
-                <a:spcPts val="1200"/>
-              </a:spcBef>
-              <a:spcAft>
-                <a:spcPts val="0"/>
-              </a:spcAft>
-              <a:buSzPts val="1800"/>
-              <a:buChar char="●"/>
-            </a:pPr>
-            <a:r>
-              <a:rPr lang="en"/>
-              <a:t>Instructor: English</a:t>
-            </a:r>
-            <a:endParaRPr/>
-          </a:p>
-          <a:p>
-            <a:pPr indent="-342900" lvl="0" marL="457200" rtl="0" algn="l">
-              <a:spcBef>
-                <a:spcPts val="0"/>
-              </a:spcBef>
-              <a:spcAft>
-                <a:spcPts val="0"/>
-              </a:spcAft>
-              <a:buSzPts val="1800"/>
-              <a:buChar char="●"/>
-            </a:pPr>
-            <a:r>
-              <a:rPr lang="en"/>
-              <a:t>Team: Choice of German or English</a:t>
+              <a:t>See Schedule tab on information index</a:t>
             </a:r>
             <a:endParaRPr/>
           </a:p>
@@ -19520,7 +19747,7 @@
       </p:sp>
       <p:sp>
         <p:nvSpPr>
-          <p:cNvPr id="263" name="Google Shape;263;p38"/>
+          <p:cNvPr id="269" name="Google Shape;269;p39"/>
           <p:cNvSpPr txBox="1"/>
           <p:nvPr>
             <p:ph idx="12" type="sldNum"/>
@@ -19599,12 +19826,12 @@
 </p:sld>
 </file>
 
-<file path=ppt/slides/slide25.xml><?xml version="1.0" encoding="utf-8"?>
+<file path=ppt/slides/slide26.xml><?xml version="1.0" encoding="utf-8"?>
 <p:sld xmlns:a="http://schemas.openxmlformats.org/drawingml/2006/main" xmlns:r="http://schemas.openxmlformats.org/officeDocument/2006/relationships" xmlns:mc="http://schemas.openxmlformats.org/markup-compatibility/2006" xmlns:mv="urn:schemas-microsoft-com:mac:vml" xmlns:p="http://schemas.openxmlformats.org/presentationml/2006/main" xmlns:c="http://schemas.openxmlformats.org/drawingml/2006/chart" xmlns:dgm="http://schemas.openxmlformats.org/drawingml/2006/diagram" xmlns:o="urn:schemas-microsoft-com:office:office" xmlns:v="urn:schemas-microsoft-com:vml" xmlns:pvml="urn:schemas-microsoft-com:office:powerpoint" xmlns:com="http://schemas.openxmlformats.org/drawingml/2006/compatibility" xmlns:p14="http://schemas.microsoft.com/office/powerpoint/2010/main" xmlns:p15="http://schemas.microsoft.com/office/powerpoint/2012/main" xmlns:ahyp="http://schemas.microsoft.com/office/drawing/2018/hyperlinkcolor">
   <p:cSld>
     <p:spTree>
       <p:nvGrpSpPr>
-        <p:cNvPr id="267" name="Shape 267"/>
+        <p:cNvPr id="273" name="Shape 273"/>
         <p:cNvGrpSpPr/>
         <p:nvPr/>
       </p:nvGrpSpPr>
@@ -19618,7 +19845,7 @@
       </p:grpSpPr>
       <p:sp>
         <p:nvSpPr>
-          <p:cNvPr id="268" name="Google Shape;268;p39"/>
+          <p:cNvPr id="274" name="Google Shape;274;p40"/>
           <p:cNvSpPr txBox="1"/>
           <p:nvPr>
             <p:ph type="title"/>
@@ -19650,7 +19877,7 @@
             </a:pPr>
             <a:r>
               <a:rPr lang="en"/>
-              <a:t>Information Index</a:t>
+              <a:t>Work Rhythm</a:t>
             </a:r>
             <a:endParaRPr/>
           </a:p>
@@ -19658,7 +19885,7 @@
       </p:sp>
       <p:sp>
         <p:nvSpPr>
-          <p:cNvPr id="269" name="Google Shape;269;p39"/>
+          <p:cNvPr id="275" name="Google Shape;275;p40"/>
           <p:cNvSpPr txBox="1"/>
           <p:nvPr>
             <p:ph idx="1" type="body"/>
@@ -19686,15 +19913,16 @@
               <a:spcAft>
                 <a:spcPts val="0"/>
               </a:spcAft>
+              <a:buClr>
+                <a:schemeClr val="dk1"/>
+              </a:buClr>
+              <a:buSzPts val="1100"/>
+              <a:buFont typeface="Arial"/>
               <a:buNone/>
             </a:pPr>
             <a:r>
               <a:rPr lang="en"/>
-              <a:t>I</a:t>
-            </a:r>
-            <a:r>
-              <a:rPr lang="en"/>
-              <a:t>nformation index</a:t>
+              <a:t>Lectures</a:t>
             </a:r>
             <a:endParaRPr/>
           </a:p>
@@ -19711,36 +19939,28 @@
             </a:pPr>
             <a:r>
               <a:rPr lang="en"/>
-              <a:t>See </a:t>
-            </a:r>
-            <a:r>
-              <a:rPr lang="en" u="sng">
-                <a:solidFill>
-                  <a:schemeClr val="hlink"/>
-                </a:solidFill>
-                <a:hlinkClick r:id="rId3"/>
-              </a:rPr>
-              <a:t>https://amos.uni1.de</a:t>
-            </a:r>
+              <a:t>Class day (90min.)</a:t>
+            </a:r>
+            <a:endParaRPr/>
+          </a:p>
+          <a:p>
+            <a:pPr indent="0" lvl="0" marL="0" rtl="0" algn="l">
+              <a:spcBef>
+                <a:spcPts val="1200"/>
+              </a:spcBef>
+              <a:spcAft>
+                <a:spcPts val="0"/>
+              </a:spcAft>
+              <a:buClr>
+                <a:schemeClr val="dk1"/>
+              </a:buClr>
+              <a:buSzPts val="1100"/>
+              <a:buFont typeface="Arial"/>
+              <a:buNone/>
+            </a:pPr>
             <a:r>
               <a:rPr lang="en"/>
-              <a:t>   </a:t>
-            </a:r>
-            <a:endParaRPr/>
-          </a:p>
-          <a:p>
-            <a:pPr indent="0" lvl="0" marL="0" rtl="0" algn="l">
-              <a:spcBef>
-                <a:spcPts val="1200"/>
-              </a:spcBef>
-              <a:spcAft>
-                <a:spcPts val="0"/>
-              </a:spcAft>
-              <a:buNone/>
-            </a:pPr>
-            <a:r>
-              <a:rPr lang="en"/>
-              <a:t>Course schedule</a:t>
+              <a:t>Team meetings</a:t>
             </a:r>
             <a:endParaRPr/>
           </a:p>
@@ -19757,7 +19977,45 @@
             </a:pPr>
             <a:r>
               <a:rPr lang="en"/>
-              <a:t>See Schedule tab on information index</a:t>
+              <a:t>Next slot after lecture</a:t>
+            </a:r>
+            <a:endParaRPr/>
+          </a:p>
+          <a:p>
+            <a:pPr indent="0" lvl="0" marL="0" rtl="0" algn="l">
+              <a:spcBef>
+                <a:spcPts val="1200"/>
+              </a:spcBef>
+              <a:spcAft>
+                <a:spcPts val="0"/>
+              </a:spcAft>
+              <a:buClr>
+                <a:schemeClr val="dk1"/>
+              </a:buClr>
+              <a:buSzPts val="1100"/>
+              <a:buFont typeface="Arial"/>
+              <a:buNone/>
+            </a:pPr>
+            <a:r>
+              <a:rPr lang="en"/>
+              <a:t>Project work (self-organized)</a:t>
+            </a:r>
+            <a:endParaRPr/>
+          </a:p>
+          <a:p>
+            <a:pPr indent="-342900" lvl="0" marL="457200" rtl="0" algn="l">
+              <a:spcBef>
+                <a:spcPts val="1200"/>
+              </a:spcBef>
+              <a:spcAft>
+                <a:spcPts val="0"/>
+              </a:spcAft>
+              <a:buSzPts val="1800"/>
+              <a:buChar char="●"/>
+            </a:pPr>
+            <a:r>
+              <a:rPr lang="en"/>
+              <a:t>Deliverables due according to schedule</a:t>
             </a:r>
             <a:endParaRPr/>
           </a:p>
@@ -19780,7 +20038,7 @@
       </p:sp>
       <p:sp>
         <p:nvSpPr>
-          <p:cNvPr id="270" name="Google Shape;270;p39"/>
+          <p:cNvPr id="276" name="Google Shape;276;p40"/>
           <p:cNvSpPr txBox="1"/>
           <p:nvPr>
             <p:ph idx="12" type="sldNum"/>
@@ -19839,7 +20097,7 @@
                 <a:solidFill>
                   <a:schemeClr val="hlink"/>
                 </a:solidFill>
-                <a:hlinkClick r:id="rId4"/>
+                <a:hlinkClick r:id="rId3"/>
               </a:rPr>
               <a:t>https://oss.cs.fau.de</a:t>
             </a:r>
@@ -19859,12 +20117,12 @@
 </p:sld>
 </file>
 
-<file path=ppt/slides/slide26.xml><?xml version="1.0" encoding="utf-8"?>
+<file path=ppt/slides/slide27.xml><?xml version="1.0" encoding="utf-8"?>
 <p:sld xmlns:a="http://schemas.openxmlformats.org/drawingml/2006/main" xmlns:r="http://schemas.openxmlformats.org/officeDocument/2006/relationships" xmlns:mc="http://schemas.openxmlformats.org/markup-compatibility/2006" xmlns:mv="urn:schemas-microsoft-com:mac:vml" xmlns:p="http://schemas.openxmlformats.org/presentationml/2006/main" xmlns:c="http://schemas.openxmlformats.org/drawingml/2006/chart" xmlns:dgm="http://schemas.openxmlformats.org/drawingml/2006/diagram" xmlns:o="urn:schemas-microsoft-com:office:office" xmlns:v="urn:schemas-microsoft-com:vml" xmlns:pvml="urn:schemas-microsoft-com:office:powerpoint" xmlns:com="http://schemas.openxmlformats.org/drawingml/2006/compatibility" xmlns:p14="http://schemas.microsoft.com/office/powerpoint/2010/main" xmlns:p15="http://schemas.microsoft.com/office/powerpoint/2012/main" xmlns:ahyp="http://schemas.microsoft.com/office/drawing/2018/hyperlinkcolor">
   <p:cSld>
     <p:spTree>
       <p:nvGrpSpPr>
-        <p:cNvPr id="274" name="Shape 274"/>
+        <p:cNvPr id="280" name="Shape 280"/>
         <p:cNvGrpSpPr/>
         <p:nvPr/>
       </p:nvGrpSpPr>
@@ -19878,7 +20136,7 @@
       </p:grpSpPr>
       <p:sp>
         <p:nvSpPr>
-          <p:cNvPr id="275" name="Google Shape;275;p40"/>
+          <p:cNvPr id="281" name="Google Shape;281;p41"/>
           <p:cNvSpPr txBox="1"/>
           <p:nvPr>
             <p:ph type="title"/>
@@ -19910,7 +20168,7 @@
             </a:pPr>
             <a:r>
               <a:rPr lang="en"/>
-              <a:t>Work Rhythm</a:t>
+              <a:t>Course Communication</a:t>
             </a:r>
             <a:endParaRPr/>
           </a:p>
@@ -19918,7 +20176,7 @@
       </p:sp>
       <p:sp>
         <p:nvSpPr>
-          <p:cNvPr id="276" name="Google Shape;276;p40"/>
+          <p:cNvPr id="282" name="Google Shape;282;p41"/>
           <p:cNvSpPr txBox="1"/>
           <p:nvPr>
             <p:ph idx="1" type="body"/>
@@ -19955,7 +20213,7 @@
             </a:pPr>
             <a:r>
               <a:rPr lang="en"/>
-              <a:t>Lectures</a:t>
+              <a:t>Announcements are sent by email</a:t>
             </a:r>
             <a:endParaRPr/>
           </a:p>
@@ -19972,35 +20230,14 @@
             </a:pPr>
             <a:r>
               <a:rPr lang="en"/>
-              <a:t>Class day (90min.)</a:t>
+              <a:t>Through email aliases</a:t>
             </a:r>
             <a:endParaRPr/>
           </a:p>
           <a:p>
-            <a:pPr indent="0" lvl="0" marL="0" rtl="0" algn="l">
-              <a:spcBef>
-                <a:spcPts val="1200"/>
-              </a:spcBef>
-              <a:spcAft>
-                <a:spcPts val="0"/>
-              </a:spcAft>
-              <a:buClr>
-                <a:schemeClr val="dk1"/>
-              </a:buClr>
-              <a:buSzPts val="1100"/>
-              <a:buFont typeface="Arial"/>
-              <a:buNone/>
-            </a:pPr>
-            <a:r>
-              <a:rPr lang="en"/>
-              <a:t>Team meetings</a:t>
-            </a:r>
-            <a:endParaRPr/>
-          </a:p>
-          <a:p>
             <a:pPr indent="-342900" lvl="0" marL="457200" rtl="0" algn="l">
               <a:spcBef>
-                <a:spcPts val="1200"/>
+                <a:spcPts val="0"/>
               </a:spcBef>
               <a:spcAft>
                 <a:spcPts val="0"/>
@@ -20010,7 +20247,7 @@
             </a:pPr>
             <a:r>
               <a:rPr lang="en"/>
-              <a:t>Next slot after lecture</a:t>
+              <a:t>Through course management system</a:t>
             </a:r>
             <a:endParaRPr/>
           </a:p>
@@ -20022,16 +20259,11 @@
               <a:spcAft>
                 <a:spcPts val="0"/>
               </a:spcAft>
-              <a:buClr>
-                <a:schemeClr val="dk1"/>
-              </a:buClr>
-              <a:buSzPts val="1100"/>
-              <a:buFont typeface="Arial"/>
               <a:buNone/>
             </a:pPr>
             <a:r>
               <a:rPr lang="en"/>
-              <a:t>Project work (self-organized)</a:t>
+              <a:t>Administrative questions to teaching team</a:t>
             </a:r>
             <a:endParaRPr/>
           </a:p>
@@ -20048,7 +20280,24 @@
             </a:pPr>
             <a:r>
               <a:rPr lang="en"/>
-              <a:t>Deliverables due according to schedule</a:t>
+              <a:t>Please ask your question in the course forum</a:t>
+            </a:r>
+            <a:endParaRPr/>
+          </a:p>
+          <a:p>
+            <a:pPr indent="-342900" lvl="0" marL="457200" rtl="0" algn="l">
+              <a:spcBef>
+                <a:spcPts val="0"/>
+              </a:spcBef>
+              <a:spcAft>
+                <a:spcPts val="0"/>
+              </a:spcAft>
+              <a:buSzPts val="1800"/>
+              <a:buChar char="●"/>
+            </a:pPr>
+            <a:r>
+              <a:rPr lang="en"/>
+              <a:t>For private questions, use the teaching team email alias</a:t>
             </a:r>
             <a:endParaRPr/>
           </a:p>
@@ -20071,7 +20320,7 @@
       </p:sp>
       <p:sp>
         <p:nvSpPr>
-          <p:cNvPr id="277" name="Google Shape;277;p40"/>
+          <p:cNvPr id="283" name="Google Shape;283;p41"/>
           <p:cNvSpPr txBox="1"/>
           <p:nvPr>
             <p:ph idx="12" type="sldNum"/>
@@ -20150,12 +20399,12 @@
 </p:sld>
 </file>
 
-<file path=ppt/slides/slide27.xml><?xml version="1.0" encoding="utf-8"?>
+<file path=ppt/slides/slide28.xml><?xml version="1.0" encoding="utf-8"?>
 <p:sld xmlns:a="http://schemas.openxmlformats.org/drawingml/2006/main" xmlns:r="http://schemas.openxmlformats.org/officeDocument/2006/relationships" xmlns:mc="http://schemas.openxmlformats.org/markup-compatibility/2006" xmlns:mv="urn:schemas-microsoft-com:mac:vml" xmlns:p="http://schemas.openxmlformats.org/presentationml/2006/main" xmlns:c="http://schemas.openxmlformats.org/drawingml/2006/chart" xmlns:dgm="http://schemas.openxmlformats.org/drawingml/2006/diagram" xmlns:o="urn:schemas-microsoft-com:office:office" xmlns:v="urn:schemas-microsoft-com:vml" xmlns:pvml="urn:schemas-microsoft-com:office:powerpoint" xmlns:com="http://schemas.openxmlformats.org/drawingml/2006/compatibility" xmlns:p14="http://schemas.microsoft.com/office/powerpoint/2010/main" xmlns:p15="http://schemas.microsoft.com/office/powerpoint/2012/main" xmlns:ahyp="http://schemas.microsoft.com/office/drawing/2018/hyperlinkcolor">
   <p:cSld>
     <p:spTree>
       <p:nvGrpSpPr>
-        <p:cNvPr id="281" name="Shape 281"/>
+        <p:cNvPr id="287" name="Shape 287"/>
         <p:cNvGrpSpPr/>
         <p:nvPr/>
       </p:nvGrpSpPr>
@@ -20169,7 +20418,191 @@
       </p:grpSpPr>
       <p:sp>
         <p:nvSpPr>
-          <p:cNvPr id="282" name="Google Shape;282;p41"/>
+          <p:cNvPr id="288" name="Google Shape;288;p42"/>
+          <p:cNvSpPr txBox="1"/>
+          <p:nvPr>
+            <p:ph type="ctrTitle"/>
+          </p:nvPr>
+        </p:nvSpPr>
+        <p:spPr>
+          <a:xfrm>
+            <a:off x="0" y="0"/>
+            <a:ext cx="9144000" cy="2388900"/>
+          </a:xfrm>
+          <a:prstGeom prst="rect">
+            <a:avLst/>
+          </a:prstGeom>
+        </p:spPr>
+        <p:txBody>
+          <a:bodyPr anchorCtr="0" anchor="b" bIns="274300" lIns="91425" spcFirstLastPara="1" rIns="91425" wrap="square" tIns="91425">
+            <a:noAutofit/>
+          </a:bodyPr>
+          <a:lstStyle/>
+          <a:p>
+            <a:pPr indent="0" lvl="0" marL="0" rtl="0" algn="ctr">
+              <a:spcBef>
+                <a:spcPts val="0"/>
+              </a:spcBef>
+              <a:spcAft>
+                <a:spcPts val="0"/>
+              </a:spcAft>
+              <a:buNone/>
+            </a:pPr>
+            <a:r>
+              <a:rPr lang="en"/>
+              <a:t>Thank you! Any questions?</a:t>
+            </a:r>
+            <a:endParaRPr/>
+          </a:p>
+        </p:txBody>
+      </p:sp>
+      <p:sp>
+        <p:nvSpPr>
+          <p:cNvPr id="289" name="Google Shape;289;p42"/>
+          <p:cNvSpPr txBox="1"/>
+          <p:nvPr>
+            <p:ph idx="1" type="subTitle"/>
+          </p:nvPr>
+        </p:nvSpPr>
+        <p:spPr>
+          <a:xfrm>
+            <a:off x="0" y="2569475"/>
+            <a:ext cx="9144000" cy="2574000"/>
+          </a:xfrm>
+          <a:prstGeom prst="rect">
+            <a:avLst/>
+          </a:prstGeom>
+        </p:spPr>
+        <p:txBody>
+          <a:bodyPr anchorCtr="0" anchor="t" bIns="91425" lIns="91425" spcFirstLastPara="1" rIns="91425" wrap="square" tIns="274300">
+            <a:noAutofit/>
+          </a:bodyPr>
+          <a:lstStyle/>
+          <a:p>
+            <a:pPr indent="0" lvl="0" marL="0" rtl="0" algn="ctr">
+              <a:lnSpc>
+                <a:spcPct val="150000"/>
+              </a:lnSpc>
+              <a:spcBef>
+                <a:spcPts val="0"/>
+              </a:spcBef>
+              <a:spcAft>
+                <a:spcPts val="0"/>
+              </a:spcAft>
+              <a:buNone/>
+            </a:pPr>
+            <a:r>
+              <a:rPr lang="en" u="sng">
+                <a:solidFill>
+                  <a:schemeClr val="hlink"/>
+                </a:solidFill>
+                <a:hlinkClick r:id="rId3"/>
+              </a:rPr>
+              <a:t>dirk.riehle@fau.de</a:t>
+            </a:r>
+            <a:r>
+              <a:rPr lang="en"/>
+              <a:t> </a:t>
+            </a:r>
+            <a:r>
+              <a:rPr lang="en" sz="2400"/>
+              <a:t>–</a:t>
+            </a:r>
+            <a:r>
+              <a:rPr lang="en"/>
+              <a:t> </a:t>
+            </a:r>
+            <a:r>
+              <a:rPr lang="en" u="sng">
+                <a:solidFill>
+                  <a:schemeClr val="hlink"/>
+                </a:solidFill>
+                <a:hlinkClick r:id="rId4"/>
+              </a:rPr>
+              <a:t>https://oss.cs.fau.de</a:t>
+            </a:r>
+            <a:endParaRPr/>
+          </a:p>
+          <a:p>
+            <a:pPr indent="0" lvl="0" marL="0" rtl="0" algn="ctr">
+              <a:lnSpc>
+                <a:spcPct val="150000"/>
+              </a:lnSpc>
+              <a:spcBef>
+                <a:spcPts val="0"/>
+              </a:spcBef>
+              <a:spcAft>
+                <a:spcPts val="0"/>
+              </a:spcAft>
+              <a:buNone/>
+            </a:pPr>
+            <a:r>
+              <a:rPr lang="en" sz="2400" u="sng">
+                <a:solidFill>
+                  <a:schemeClr val="hlink"/>
+                </a:solidFill>
+                <a:hlinkClick r:id="rId5"/>
+              </a:rPr>
+              <a:t>dirk@riehle.org</a:t>
+            </a:r>
+            <a:r>
+              <a:rPr lang="en" sz="2400"/>
+              <a:t> – </a:t>
+            </a:r>
+            <a:r>
+              <a:rPr lang="en" sz="2400" u="sng">
+                <a:solidFill>
+                  <a:schemeClr val="hlink"/>
+                </a:solidFill>
+                <a:hlinkClick r:id="rId6"/>
+              </a:rPr>
+              <a:t>https://dirkriehle.com</a:t>
+            </a:r>
+            <a:r>
+              <a:rPr lang="en" sz="2400"/>
+              <a:t> – </a:t>
+            </a:r>
+            <a:r>
+              <a:rPr lang="en" sz="2400" u="sng">
+                <a:solidFill>
+                  <a:schemeClr val="hlink"/>
+                </a:solidFill>
+                <a:hlinkClick r:id="rId7"/>
+              </a:rPr>
+              <a:t>@dirkriehle</a:t>
+            </a:r>
+            <a:endParaRPr sz="2400"/>
+          </a:p>
+        </p:txBody>
+      </p:sp>
+    </p:spTree>
+  </p:cSld>
+  <p:clrMapOvr>
+    <a:masterClrMapping/>
+  </p:clrMapOvr>
+</p:sld>
+</file>
+
+<file path=ppt/slides/slide29.xml><?xml version="1.0" encoding="utf-8"?>
+<p:sld xmlns:a="http://schemas.openxmlformats.org/drawingml/2006/main" xmlns:r="http://schemas.openxmlformats.org/officeDocument/2006/relationships" xmlns:mc="http://schemas.openxmlformats.org/markup-compatibility/2006" xmlns:mv="urn:schemas-microsoft-com:mac:vml" xmlns:p="http://schemas.openxmlformats.org/presentationml/2006/main" xmlns:c="http://schemas.openxmlformats.org/drawingml/2006/chart" xmlns:dgm="http://schemas.openxmlformats.org/drawingml/2006/diagram" xmlns:o="urn:schemas-microsoft-com:office:office" xmlns:v="urn:schemas-microsoft-com:vml" xmlns:pvml="urn:schemas-microsoft-com:office:powerpoint" xmlns:com="http://schemas.openxmlformats.org/drawingml/2006/compatibility" xmlns:p14="http://schemas.microsoft.com/office/powerpoint/2010/main" xmlns:p15="http://schemas.microsoft.com/office/powerpoint/2012/main" xmlns:ahyp="http://schemas.microsoft.com/office/drawing/2018/hyperlinkcolor">
+  <p:cSld>
+    <p:spTree>
+      <p:nvGrpSpPr>
+        <p:cNvPr id="293" name="Shape 293"/>
+        <p:cNvGrpSpPr/>
+        <p:nvPr/>
+      </p:nvGrpSpPr>
+      <p:grpSpPr>
+        <a:xfrm>
+          <a:off x="0" y="0"/>
+          <a:ext cx="0" cy="0"/>
+          <a:chOff x="0" y="0"/>
+          <a:chExt cx="0" cy="0"/>
+        </a:xfrm>
+      </p:grpSpPr>
+      <p:sp>
+        <p:nvSpPr>
+          <p:cNvPr id="294" name="Google Shape;294;p43"/>
           <p:cNvSpPr txBox="1"/>
           <p:nvPr>
             <p:ph type="title"/>
@@ -20201,7 +20634,7 @@
             </a:pPr>
             <a:r>
               <a:rPr lang="en"/>
-              <a:t>Course Communication</a:t>
+              <a:t>Legal Notices</a:t>
             </a:r>
             <a:endParaRPr/>
           </a:p>
@@ -20209,151 +20642,7 @@
       </p:sp>
       <p:sp>
         <p:nvSpPr>
-          <p:cNvPr id="283" name="Google Shape;283;p41"/>
-          <p:cNvSpPr txBox="1"/>
-          <p:nvPr>
-            <p:ph idx="1" type="body"/>
-          </p:nvPr>
-        </p:nvSpPr>
-        <p:spPr>
-          <a:xfrm>
-            <a:off x="274320" y="914400"/>
-            <a:ext cx="8595300" cy="4114800"/>
-          </a:xfrm>
-          <a:prstGeom prst="rect">
-            <a:avLst/>
-          </a:prstGeom>
-        </p:spPr>
-        <p:txBody>
-          <a:bodyPr anchorCtr="0" anchor="t" bIns="0" lIns="0" spcFirstLastPara="1" rIns="0" wrap="square" tIns="0">
-            <a:noAutofit/>
-          </a:bodyPr>
-          <a:lstStyle/>
-          <a:p>
-            <a:pPr indent="0" lvl="0" marL="0" rtl="0" algn="l">
-              <a:spcBef>
-                <a:spcPts val="0"/>
-              </a:spcBef>
-              <a:spcAft>
-                <a:spcPts val="0"/>
-              </a:spcAft>
-              <a:buClr>
-                <a:schemeClr val="dk1"/>
-              </a:buClr>
-              <a:buSzPts val="1100"/>
-              <a:buFont typeface="Arial"/>
-              <a:buNone/>
-            </a:pPr>
-            <a:r>
-              <a:rPr lang="en"/>
-              <a:t>Announcements are sent by email</a:t>
-            </a:r>
-            <a:endParaRPr/>
-          </a:p>
-          <a:p>
-            <a:pPr indent="-342900" lvl="0" marL="457200" rtl="0" algn="l">
-              <a:spcBef>
-                <a:spcPts val="1200"/>
-              </a:spcBef>
-              <a:spcAft>
-                <a:spcPts val="0"/>
-              </a:spcAft>
-              <a:buSzPts val="1800"/>
-              <a:buChar char="●"/>
-            </a:pPr>
-            <a:r>
-              <a:rPr lang="en"/>
-              <a:t>Through email aliases</a:t>
-            </a:r>
-            <a:endParaRPr/>
-          </a:p>
-          <a:p>
-            <a:pPr indent="-342900" lvl="0" marL="457200" rtl="0" algn="l">
-              <a:spcBef>
-                <a:spcPts val="0"/>
-              </a:spcBef>
-              <a:spcAft>
-                <a:spcPts val="0"/>
-              </a:spcAft>
-              <a:buSzPts val="1800"/>
-              <a:buChar char="●"/>
-            </a:pPr>
-            <a:r>
-              <a:rPr lang="en"/>
-              <a:t>Through course management system</a:t>
-            </a:r>
-            <a:endParaRPr/>
-          </a:p>
-          <a:p>
-            <a:pPr indent="0" lvl="0" marL="0" rtl="0" algn="l">
-              <a:spcBef>
-                <a:spcPts val="1200"/>
-              </a:spcBef>
-              <a:spcAft>
-                <a:spcPts val="0"/>
-              </a:spcAft>
-              <a:buNone/>
-            </a:pPr>
-            <a:r>
-              <a:rPr lang="en"/>
-              <a:t>Administrative questions to teaching team</a:t>
-            </a:r>
-            <a:endParaRPr/>
-          </a:p>
-          <a:p>
-            <a:pPr indent="-342900" lvl="0" marL="457200" rtl="0" algn="l">
-              <a:spcBef>
-                <a:spcPts val="1200"/>
-              </a:spcBef>
-              <a:spcAft>
-                <a:spcPts val="0"/>
-              </a:spcAft>
-              <a:buSzPts val="1800"/>
-              <a:buChar char="●"/>
-            </a:pPr>
-            <a:r>
-              <a:rPr lang="en"/>
-              <a:t>Please ask your question in the course forum</a:t>
-            </a:r>
-            <a:endParaRPr/>
-          </a:p>
-          <a:p>
-            <a:pPr indent="-342900" lvl="0" marL="457200" rtl="0" algn="l">
-              <a:spcBef>
-                <a:spcPts val="0"/>
-              </a:spcBef>
-              <a:spcAft>
-                <a:spcPts val="0"/>
-              </a:spcAft>
-              <a:buSzPts val="1800"/>
-              <a:buChar char="●"/>
-            </a:pPr>
-            <a:r>
-              <a:rPr lang="en"/>
-              <a:t>For private questions, use the teaching team email alias</a:t>
-            </a:r>
-            <a:endParaRPr/>
-          </a:p>
-          <a:p>
-            <a:pPr indent="0" lvl="0" marL="0" rtl="0" algn="l">
-              <a:spcBef>
-                <a:spcPts val="1200"/>
-              </a:spcBef>
-              <a:spcAft>
-                <a:spcPts val="1200"/>
-              </a:spcAft>
-              <a:buNone/>
-            </a:pPr>
-            <a:r>
-              <a:t/>
-            </a:r>
-            <a:endParaRPr/>
-          </a:p>
-        </p:txBody>
-      </p:sp>
-      <p:sp>
-        <p:nvSpPr>
-          <p:cNvPr id="284" name="Google Shape;284;p41"/>
+          <p:cNvPr id="295" name="Google Shape;295;p43"/>
           <p:cNvSpPr txBox="1"/>
           <p:nvPr>
             <p:ph idx="12" type="sldNum"/>
@@ -20424,331 +20713,9 @@
           </a:p>
         </p:txBody>
       </p:sp>
-    </p:spTree>
-  </p:cSld>
-  <p:clrMapOvr>
-    <a:masterClrMapping/>
-  </p:clrMapOvr>
-</p:sld>
-</file>
-
-<file path=ppt/slides/slide28.xml><?xml version="1.0" encoding="utf-8"?>
-<p:sld xmlns:a="http://schemas.openxmlformats.org/drawingml/2006/main" xmlns:r="http://schemas.openxmlformats.org/officeDocument/2006/relationships" xmlns:mc="http://schemas.openxmlformats.org/markup-compatibility/2006" xmlns:mv="urn:schemas-microsoft-com:mac:vml" xmlns:p="http://schemas.openxmlformats.org/presentationml/2006/main" xmlns:c="http://schemas.openxmlformats.org/drawingml/2006/chart" xmlns:dgm="http://schemas.openxmlformats.org/drawingml/2006/diagram" xmlns:o="urn:schemas-microsoft-com:office:office" xmlns:v="urn:schemas-microsoft-com:vml" xmlns:pvml="urn:schemas-microsoft-com:office:powerpoint" xmlns:com="http://schemas.openxmlformats.org/drawingml/2006/compatibility" xmlns:p14="http://schemas.microsoft.com/office/powerpoint/2010/main" xmlns:p15="http://schemas.microsoft.com/office/powerpoint/2012/main" xmlns:ahyp="http://schemas.microsoft.com/office/drawing/2018/hyperlinkcolor">
-  <p:cSld>
-    <p:spTree>
-      <p:nvGrpSpPr>
-        <p:cNvPr id="288" name="Shape 288"/>
-        <p:cNvGrpSpPr/>
-        <p:nvPr/>
-      </p:nvGrpSpPr>
-      <p:grpSpPr>
-        <a:xfrm>
-          <a:off x="0" y="0"/>
-          <a:ext cx="0" cy="0"/>
-          <a:chOff x="0" y="0"/>
-          <a:chExt cx="0" cy="0"/>
-        </a:xfrm>
-      </p:grpSpPr>
-      <p:sp>
-        <p:nvSpPr>
-          <p:cNvPr id="289" name="Google Shape;289;p42"/>
-          <p:cNvSpPr txBox="1"/>
-          <p:nvPr>
-            <p:ph type="ctrTitle"/>
-          </p:nvPr>
-        </p:nvSpPr>
-        <p:spPr>
-          <a:xfrm>
-            <a:off x="0" y="0"/>
-            <a:ext cx="9144000" cy="2388900"/>
-          </a:xfrm>
-          <a:prstGeom prst="rect">
-            <a:avLst/>
-          </a:prstGeom>
-        </p:spPr>
-        <p:txBody>
-          <a:bodyPr anchorCtr="0" anchor="b" bIns="274300" lIns="91425" spcFirstLastPara="1" rIns="91425" wrap="square" tIns="91425">
-            <a:noAutofit/>
-          </a:bodyPr>
-          <a:lstStyle/>
-          <a:p>
-            <a:pPr indent="0" lvl="0" marL="0" rtl="0" algn="ctr">
-              <a:spcBef>
-                <a:spcPts val="0"/>
-              </a:spcBef>
-              <a:spcAft>
-                <a:spcPts val="0"/>
-              </a:spcAft>
-              <a:buNone/>
-            </a:pPr>
-            <a:r>
-              <a:rPr lang="en"/>
-              <a:t>Thank you! Any questions?</a:t>
-            </a:r>
-            <a:endParaRPr/>
-          </a:p>
-        </p:txBody>
-      </p:sp>
-      <p:sp>
-        <p:nvSpPr>
-          <p:cNvPr id="290" name="Google Shape;290;p42"/>
-          <p:cNvSpPr txBox="1"/>
-          <p:nvPr>
-            <p:ph idx="1" type="subTitle"/>
-          </p:nvPr>
-        </p:nvSpPr>
-        <p:spPr>
-          <a:xfrm>
-            <a:off x="0" y="2569475"/>
-            <a:ext cx="9144000" cy="2574000"/>
-          </a:xfrm>
-          <a:prstGeom prst="rect">
-            <a:avLst/>
-          </a:prstGeom>
-        </p:spPr>
-        <p:txBody>
-          <a:bodyPr anchorCtr="0" anchor="t" bIns="91425" lIns="91425" spcFirstLastPara="1" rIns="91425" wrap="square" tIns="274300">
-            <a:noAutofit/>
-          </a:bodyPr>
-          <a:lstStyle/>
-          <a:p>
-            <a:pPr indent="0" lvl="0" marL="0" rtl="0" algn="ctr">
-              <a:lnSpc>
-                <a:spcPct val="150000"/>
-              </a:lnSpc>
-              <a:spcBef>
-                <a:spcPts val="0"/>
-              </a:spcBef>
-              <a:spcAft>
-                <a:spcPts val="0"/>
-              </a:spcAft>
-              <a:buNone/>
-            </a:pPr>
-            <a:r>
-              <a:rPr lang="en" u="sng">
-                <a:solidFill>
-                  <a:schemeClr val="hlink"/>
-                </a:solidFill>
-                <a:hlinkClick r:id="rId3"/>
-              </a:rPr>
-              <a:t>dirk.riehle@fau.de</a:t>
-            </a:r>
-            <a:r>
-              <a:rPr lang="en"/>
-              <a:t> </a:t>
-            </a:r>
-            <a:r>
-              <a:rPr lang="en" sz="2400"/>
-              <a:t>–</a:t>
-            </a:r>
-            <a:r>
-              <a:rPr lang="en"/>
-              <a:t> </a:t>
-            </a:r>
-            <a:r>
-              <a:rPr lang="en" u="sng">
-                <a:solidFill>
-                  <a:schemeClr val="hlink"/>
-                </a:solidFill>
-                <a:hlinkClick r:id="rId4"/>
-              </a:rPr>
-              <a:t>https://oss.cs.fau.de</a:t>
-            </a:r>
-            <a:endParaRPr/>
-          </a:p>
-          <a:p>
-            <a:pPr indent="0" lvl="0" marL="0" rtl="0" algn="ctr">
-              <a:lnSpc>
-                <a:spcPct val="150000"/>
-              </a:lnSpc>
-              <a:spcBef>
-                <a:spcPts val="0"/>
-              </a:spcBef>
-              <a:spcAft>
-                <a:spcPts val="0"/>
-              </a:spcAft>
-              <a:buNone/>
-            </a:pPr>
-            <a:r>
-              <a:rPr lang="en" sz="2400" u="sng">
-                <a:solidFill>
-                  <a:schemeClr val="hlink"/>
-                </a:solidFill>
-                <a:hlinkClick r:id="rId5"/>
-              </a:rPr>
-              <a:t>dirk@riehle.org</a:t>
-            </a:r>
-            <a:r>
-              <a:rPr lang="en" sz="2400"/>
-              <a:t> – </a:t>
-            </a:r>
-            <a:r>
-              <a:rPr lang="en" sz="2400" u="sng">
-                <a:solidFill>
-                  <a:schemeClr val="hlink"/>
-                </a:solidFill>
-                <a:hlinkClick r:id="rId6"/>
-              </a:rPr>
-              <a:t>https://dirkriehle.com</a:t>
-            </a:r>
-            <a:r>
-              <a:rPr lang="en" sz="2400"/>
-              <a:t> – </a:t>
-            </a:r>
-            <a:r>
-              <a:rPr lang="en" sz="2400" u="sng">
-                <a:solidFill>
-                  <a:schemeClr val="hlink"/>
-                </a:solidFill>
-                <a:hlinkClick r:id="rId7"/>
-              </a:rPr>
-              <a:t>@dirkriehle</a:t>
-            </a:r>
-            <a:endParaRPr sz="2400"/>
-          </a:p>
-        </p:txBody>
-      </p:sp>
-    </p:spTree>
-  </p:cSld>
-  <p:clrMapOvr>
-    <a:masterClrMapping/>
-  </p:clrMapOvr>
-</p:sld>
-</file>
-
-<file path=ppt/slides/slide29.xml><?xml version="1.0" encoding="utf-8"?>
-<p:sld xmlns:a="http://schemas.openxmlformats.org/drawingml/2006/main" xmlns:r="http://schemas.openxmlformats.org/officeDocument/2006/relationships" xmlns:mc="http://schemas.openxmlformats.org/markup-compatibility/2006" xmlns:mv="urn:schemas-microsoft-com:mac:vml" xmlns:p="http://schemas.openxmlformats.org/presentationml/2006/main" xmlns:c="http://schemas.openxmlformats.org/drawingml/2006/chart" xmlns:dgm="http://schemas.openxmlformats.org/drawingml/2006/diagram" xmlns:o="urn:schemas-microsoft-com:office:office" xmlns:v="urn:schemas-microsoft-com:vml" xmlns:pvml="urn:schemas-microsoft-com:office:powerpoint" xmlns:com="http://schemas.openxmlformats.org/drawingml/2006/compatibility" xmlns:p14="http://schemas.microsoft.com/office/powerpoint/2010/main" xmlns:p15="http://schemas.microsoft.com/office/powerpoint/2012/main" xmlns:ahyp="http://schemas.microsoft.com/office/drawing/2018/hyperlinkcolor">
-  <p:cSld>
-    <p:spTree>
-      <p:nvGrpSpPr>
-        <p:cNvPr id="294" name="Shape 294"/>
-        <p:cNvGrpSpPr/>
-        <p:nvPr/>
-      </p:nvGrpSpPr>
-      <p:grpSpPr>
-        <a:xfrm>
-          <a:off x="0" y="0"/>
-          <a:ext cx="0" cy="0"/>
-          <a:chOff x="0" y="0"/>
-          <a:chExt cx="0" cy="0"/>
-        </a:xfrm>
-      </p:grpSpPr>
-      <p:sp>
-        <p:nvSpPr>
-          <p:cNvPr id="295" name="Google Shape;295;p43"/>
-          <p:cNvSpPr txBox="1"/>
-          <p:nvPr>
-            <p:ph type="title"/>
-          </p:nvPr>
-        </p:nvSpPr>
-        <p:spPr>
-          <a:xfrm>
-            <a:off x="0" y="0"/>
-            <a:ext cx="9144000" cy="685800"/>
-          </a:xfrm>
-          <a:prstGeom prst="rect">
-            <a:avLst/>
-          </a:prstGeom>
-        </p:spPr>
-        <p:txBody>
-          <a:bodyPr anchorCtr="0" anchor="ctr" bIns="91425" lIns="274300" spcFirstLastPara="1" rIns="91425" wrap="square" tIns="91425">
-            <a:noAutofit/>
-          </a:bodyPr>
-          <a:lstStyle/>
-          <a:p>
-            <a:pPr indent="0" lvl="0" marL="0" rtl="0" algn="l">
-              <a:spcBef>
-                <a:spcPts val="0"/>
-              </a:spcBef>
-              <a:spcAft>
-                <a:spcPts val="0"/>
-              </a:spcAft>
-              <a:buNone/>
-            </a:pPr>
-            <a:r>
-              <a:rPr lang="en"/>
-              <a:t>Legal Notices</a:t>
-            </a:r>
-            <a:endParaRPr/>
-          </a:p>
-        </p:txBody>
-      </p:sp>
       <p:sp>
         <p:nvSpPr>
           <p:cNvPr id="296" name="Google Shape;296;p43"/>
-          <p:cNvSpPr txBox="1"/>
-          <p:nvPr>
-            <p:ph idx="12" type="sldNum"/>
-          </p:nvPr>
-        </p:nvSpPr>
-        <p:spPr>
-          <a:xfrm>
-            <a:off x="7315202" y="4416550"/>
-            <a:ext cx="1828800" cy="731400"/>
-          </a:xfrm>
-          <a:prstGeom prst="rect">
-            <a:avLst/>
-          </a:prstGeom>
-        </p:spPr>
-        <p:txBody>
-          <a:bodyPr anchorCtr="0" anchor="b" bIns="91425" lIns="91425" spcFirstLastPara="1" rIns="91425" wrap="square" tIns="91425">
-            <a:noAutofit/>
-          </a:bodyPr>
-          <a:lstStyle/>
-          <a:p>
-            <a:pPr indent="0" lvl="0" marL="0" rtl="0" algn="r">
-              <a:spcBef>
-                <a:spcPts val="0"/>
-              </a:spcBef>
-              <a:spcAft>
-                <a:spcPts val="0"/>
-              </a:spcAft>
-              <a:buNone/>
-            </a:pPr>
-            <a:fld id="{00000000-1234-1234-1234-123412341234}" type="slidenum">
-              <a:rPr lang="en">
-                <a:solidFill>
-                  <a:schemeClr val="dk1"/>
-                </a:solidFill>
-              </a:rPr>
-              <a:t>‹#›</a:t>
-            </a:fld>
-            <a:endParaRPr>
-              <a:solidFill>
-                <a:schemeClr val="dk1"/>
-              </a:solidFill>
-            </a:endParaRPr>
-          </a:p>
-          <a:p>
-            <a:pPr indent="0" lvl="0" marL="0" rtl="0" algn="r">
-              <a:spcBef>
-                <a:spcPts val="0"/>
-              </a:spcBef>
-              <a:spcAft>
-                <a:spcPts val="0"/>
-              </a:spcAft>
-              <a:buNone/>
-            </a:pPr>
-            <a:r>
-              <a:rPr b="0" lang="en" sz="900" u="sng">
-                <a:solidFill>
-                  <a:schemeClr val="hlink"/>
-                </a:solidFill>
-                <a:hlinkClick r:id="rId3"/>
-              </a:rPr>
-              <a:t>https://oss.cs.fau.de</a:t>
-            </a:r>
-            <a:r>
-              <a:rPr b="0" lang="en" sz="900"/>
-              <a:t> </a:t>
-            </a:r>
-            <a:endParaRPr b="0" sz="900"/>
-          </a:p>
-        </p:txBody>
-      </p:sp>
-      <p:sp>
-        <p:nvSpPr>
-          <p:cNvPr id="297" name="Google Shape;297;p43"/>
           <p:cNvSpPr txBox="1"/>
           <p:nvPr>
             <p:ph idx="1" type="body"/>
@@ -21224,7 +21191,7 @@
   <p:cSld>
     <p:spTree>
       <p:nvGrpSpPr>
-        <p:cNvPr id="301" name="Shape 301"/>
+        <p:cNvPr id="300" name="Shape 300"/>
         <p:cNvGrpSpPr/>
         <p:nvPr/>
       </p:nvGrpSpPr>
@@ -21238,7 +21205,7 @@
       </p:grpSpPr>
       <p:sp>
         <p:nvSpPr>
-          <p:cNvPr id="302" name="Google Shape;302;p44"/>
+          <p:cNvPr id="301" name="Google Shape;301;p44"/>
           <p:cNvSpPr txBox="1"/>
           <p:nvPr>
             <p:ph type="title"/>
@@ -21278,7 +21245,7 @@
       </p:sp>
       <p:sp>
         <p:nvSpPr>
-          <p:cNvPr id="303" name="Google Shape;303;p44"/>
+          <p:cNvPr id="302" name="Google Shape;302;p44"/>
           <p:cNvSpPr txBox="1"/>
           <p:nvPr>
             <p:ph idx="1" type="body"/>
@@ -21466,7 +21433,7 @@
       </p:sp>
       <p:sp>
         <p:nvSpPr>
-          <p:cNvPr id="304" name="Google Shape;304;p44"/>
+          <p:cNvPr id="303" name="Google Shape;303;p44"/>
           <p:cNvSpPr txBox="1"/>
           <p:nvPr>
             <p:ph idx="12" type="sldNum"/>
@@ -21968,7 +21935,7 @@
                 </a:solidFill>
                 <a:hlinkClick r:id="rId3"/>
               </a:rPr>
-              <a:t>https://oss.cs.fau.de</a:t>
+              <a:t>https://uni1.de/amos</a:t>
             </a:r>
             <a:r>
               <a:rPr b="0" lang="en" sz="900">
@@ -22139,7 +22106,7 @@
             <a:tbl>
               <a:tblPr>
                 <a:noFill/>
-                <a:tableStyleId>{AB67F2C7-E277-495E-AD0F-626B15EC63A6}</a:tableStyleId>
+                <a:tableStyleId>{7EA05E9F-FED0-4B2F-B344-BC6183A9FCCF}</a:tableStyleId>
               </a:tblPr>
               <a:tblGrid>
                 <a:gridCol w="859550"/>
@@ -27284,7 +27251,7 @@
 </file>
 
 <file path=ppt/theme/theme1.xml><?xml version="1.0" encoding="utf-8"?>
-<a:theme xmlns:a="http://schemas.openxmlformats.org/drawingml/2006/main" xmlns:r="http://schemas.openxmlformats.org/officeDocument/2006/relationships" name="POSS Slides Template">
+<a:theme xmlns:a="http://schemas.openxmlformats.org/drawingml/2006/main" xmlns:r="http://schemas.openxmlformats.org/officeDocument/2006/relationships" name="AMOS Slides Template">
   <a:themeElements>
     <a:clrScheme name="Simple Light">
       <a:dk1>
@@ -27563,7 +27530,7 @@
 </file>
 
 <file path=ppt/theme/theme2.xml><?xml version="1.0" encoding="utf-8"?>
-<a:theme xmlns:a="http://schemas.openxmlformats.org/drawingml/2006/main" xmlns:r="http://schemas.openxmlformats.org/officeDocument/2006/relationships" name="AMOS Slides Template">
+<a:theme xmlns:a="http://schemas.openxmlformats.org/drawingml/2006/main" xmlns:r="http://schemas.openxmlformats.org/officeDocument/2006/relationships" name="POSS Slides Template">
   <a:themeElements>
     <a:clrScheme name="Simple Light">
       <a:dk1>

</xml_diff>